<commit_message>
added my JSON collection
</commit_message>
<xml_diff>
--- a/Docs/Cairo_Presentation_v2.pptx
+++ b/Docs/Cairo_Presentation_v2.pptx
@@ -291,23 +291,7 @@
           <a:bodyPr/>
           <a:lstStyle/>
           <a:p>
-            <a:r>
-              <a:rPr lang="en-US" dirty="0"/>
-              <a:t>"Hi everyone, my name is Maria Aguilar and today I'm presenting Cairo — my capstone project for UCI 2123. Cairo is a project management web application, similar to Jira, that I built completely from scratch in 7 days using React on the frontend and Spring Boot on the backend with a MySQL database."</a:t>
-            </a:r>
-          </a:p>
-          <a:p>
-            <a:r>
-              <a:rPr lang="en-US" i="1" dirty="0"/>
-              <a:t>Point to the fun fact card:</a:t>
-            </a:r>
             <a:endParaRPr lang="en-US" dirty="0"/>
-          </a:p>
-          <a:p>
-            <a:r>
-              <a:rPr lang="en-US" dirty="0"/>
-              <a:t>"I named it Cairo after my son. His name means 'The Victorious' in Arabic — and I thought that was fitting for a capstone project. I also did some research and found out that Jira is actually short for Gojira, which is the Japanese name for Godzilla. So I built a project management tool named after my victorious son to take on Godzilla."</a:t>
-            </a:r>
           </a:p>
         </p:txBody>
       </p:sp>
@@ -391,34 +375,6 @@
           <a:bodyPr/>
           <a:lstStyle/>
           <a:p>
-            <a:r>
-              <a:rPr lang="en-US" dirty="0"/>
-              <a:t>The feature I most want to add is an AI assistant. The idea is that instead of a project manager manually sorting through the backlog and deciding what goes into the next sprint, an AI would </a:t>
-            </a:r>
-            <a:r>
-              <a:rPr lang="en-US" dirty="0" err="1"/>
-              <a:t>analyse</a:t>
-            </a:r>
-            <a:r>
-              <a:rPr lang="en-US" dirty="0"/>
-              <a:t> the history of the project — how long things actually take, who finishes work fastest, what's been sitting unfinished the longest — and make recommendations automatically. It could also generate a stand-up summary by just reading the issue history, which would save teams a lot of time."</a:t>
-            </a:r>
-          </a:p>
-          <a:p>
-            <a:r>
-              <a:rPr lang="en-US" dirty="0"/>
-              <a:t>Beyond that I'd want to add a mobile app, real-time notifications using </a:t>
-            </a:r>
-            <a:r>
-              <a:rPr lang="en-US" dirty="0" err="1"/>
-              <a:t>WebSockets</a:t>
-            </a:r>
-            <a:r>
-              <a:rPr lang="en-US" dirty="0"/>
-              <a:t> instead of the polling I'm doing now, analytics dashboards, and integrations with tools like GitHub and Slack.</a:t>
-            </a:r>
-          </a:p>
-          <a:p>
             <a:endParaRPr lang="en-US" dirty="0"/>
           </a:p>
         </p:txBody>
@@ -503,10 +459,7 @@
           <a:bodyPr/>
           <a:lstStyle/>
           <a:p>
-            <a:r>
-              <a:rPr lang="en-US" dirty="0"/>
-              <a:t>That's Cairo. A full-stack project management application built in 7 days, named after my son, designed to replace Godzilla. I'm happy to take any questions.</a:t>
-            </a:r>
+            <a:endParaRPr lang="en-US" dirty="0"/>
           </a:p>
         </p:txBody>
       </p:sp>
@@ -590,24 +543,6 @@
           <a:bodyPr/>
           <a:lstStyle/>
           <a:p>
-            <a:r>
-              <a:rPr lang="en-US" dirty="0"/>
-              <a:t>The problem I'm solving is that tools like Jira are expensive and overwhelming for beginners. Teams pay $8 to $15 per person every month. The setup is complicated. And if you've never used a project management tool before, Jira can feel like too much all at once."</a:t>
-            </a:r>
-          </a:p>
-          <a:p>
-            <a:r>
-              <a:rPr lang="en-US" dirty="0"/>
-              <a:t>"Cairo fixes that. It's completely free, self-hosted, and simple by design. My vision for Cairo is that it could be used in coding bootcamps and university programs — like this one — as a starting point. You learn the core concepts: sprints, Kanban boards, issue tracking, team collaboration. You get comfortable with how project management actually works. Then when you go into industry and use Jira or similar tools, you already understand the fundamentals. Cairo is the stepping stone."</a:t>
-            </a:r>
-          </a:p>
-          <a:p>
-            <a:r>
-              <a:rPr lang="en-US" dirty="0"/>
-              <a:t>"On top of that — it's self-hosted, so your data never leaves your own machine, and the README gets you running in minutes.</a:t>
-            </a:r>
-          </a:p>
-          <a:p>
             <a:endParaRPr lang="en-US" dirty="0"/>
           </a:p>
         </p:txBody>
@@ -692,51 +627,6 @@
           <a:bodyPr/>
           <a:lstStyle/>
           <a:p>
-            <a:r>
-              <a:rPr lang="en-US" dirty="0"/>
-              <a:t>Cairo is split into three layers — the frontend, the backend, and the database. Let me walk through each one."</a:t>
-            </a:r>
-          </a:p>
-          <a:p>
-            <a:r>
-              <a:rPr lang="en-US" i="1" dirty="0"/>
-              <a:t>Point to Frontend:</a:t>
-            </a:r>
-            <a:endParaRPr lang="en-US" dirty="0"/>
-          </a:p>
-          <a:p>
-            <a:r>
-              <a:rPr lang="en-US" dirty="0"/>
-              <a:t>"The frontend is built with React 18 and Vite. React is a JavaScript library for building user interfaces. Vite is the tool that runs and builds the project. I used React Router to handle navigation between 10 pages. Three are public — the homepage, login, and register. The other seven are protected, meaning you have to be logged in to access them. If you try to visit a protected page without being logged in, React Router automatically redirects you to the login page. There's also an Admin Panel page that's only visible in the sidebar when your account has the ADMIN role.</a:t>
-            </a:r>
-          </a:p>
-          <a:p>
-            <a:r>
-              <a:rPr lang="en-US" i="1" dirty="0"/>
-              <a:t>Point to Backend:</a:t>
-            </a:r>
-            <a:endParaRPr lang="en-US" dirty="0"/>
-          </a:p>
-          <a:p>
-            <a:r>
-              <a:rPr lang="en-US" dirty="0"/>
-              <a:t>"The backend is built with Spring Boot, which is a Java framework for building REST APIs. A REST API is basically a set of URLs that the frontend calls to get or save data. I have 7 controllers — one for each major feature: authentication, users, projects, sprints, issues, comments, and notifications. Each controller talks to a service layer, which is where all the business logic lives. I also built a Global Exception Handler, which means whenever something goes wrong, the API always returns a clear error message with the right error code instead of just crashing."</a:t>
-            </a:r>
-          </a:p>
-          <a:p>
-            <a:r>
-              <a:rPr lang="en-US" i="1" dirty="0"/>
-              <a:t>Point to Database:</a:t>
-            </a:r>
-            <a:endParaRPr lang="en-US" dirty="0"/>
-          </a:p>
-          <a:p>
-            <a:r>
-              <a:rPr lang="en-US" dirty="0"/>
-              <a:t>"The database is MySQL. I designed 10 tables before I wrote a single line of code. The tables store everything — users, projects, sprints, issues, comments, and a history of every change made to an issue."</a:t>
-            </a:r>
-          </a:p>
-          <a:p>
             <a:endParaRPr lang="en-US" dirty="0"/>
           </a:p>
         </p:txBody>
@@ -821,18 +711,6 @@
           <a:bodyPr/>
           <a:lstStyle/>
           <a:p>
-            <a:r>
-              <a:rPr lang="en-US" dirty="0"/>
-              <a:t>This is the database diagram I designed using a tool called </a:t>
-            </a:r>
-            <a:r>
-              <a:rPr lang="en-US" dirty="0" err="1"/>
-              <a:t>DrawSQL</a:t>
-            </a:r>
-            <a:r>
-              <a:rPr lang="en-US" dirty="0"/>
-              <a:t>. Each box is a table and the lines between them show how they're connected. The most important table is issues — it connects to projects, sprints, the user who created it, and the user it's assigned to. It also connects to comments, labels, and the history table that tracks every status change. I built this diagram on Day 1 and it saved me a lot of time because I never had to go back and change the database structure</a:t>
-            </a:r>
             <a:endParaRPr lang="en-US" i="0" u="none" dirty="0"/>
           </a:p>
         </p:txBody>
@@ -917,19 +795,7 @@
           <a:bodyPr/>
           <a:lstStyle/>
           <a:p>
-            <a:r>
-              <a:rPr lang="en-US" dirty="0"/>
-              <a:t>"Before I started building, I defined 12 user stories. A user story is a description of a feature from the perspective of the person using it. For example — 'As a developer, I want to create an issue so I can track work— Developer(User), Project Manager(Admin). </a:t>
-            </a:r>
-          </a:p>
-          <a:p>
             <a:endParaRPr lang="en-US" dirty="0"/>
-          </a:p>
-          <a:p>
-            <a:r>
-              <a:rPr lang="en-US" dirty="0"/>
-              <a:t>"Developers can create and update issues, assign them to teammates, comment on them, and receive notifications when something changes. Project Managers can create projects, add team members, manage sprints through their full lifecycle — pending, active, completed — and view the Kanban board. Admins can register users, assign roles, and remove members from projects."</a:t>
-            </a:r>
           </a:p>
         </p:txBody>
       </p:sp>
@@ -1013,10 +879,7 @@
           <a:bodyPr/>
           <a:lstStyle/>
           <a:p>
-            <a:r>
-              <a:rPr lang="en-US" dirty="0"/>
-              <a:t>Login first</a:t>
-            </a:r>
+            <a:endParaRPr lang="en-US" dirty="0"/>
           </a:p>
         </p:txBody>
       </p:sp>
@@ -1100,146 +963,6 @@
           <a:bodyPr/>
           <a:lstStyle/>
           <a:p>
-            <a:r>
-              <a:rPr lang="en-US" dirty="0"/>
-              <a:t>"I want to show you the most interesting piece of code I wrote — this is the status update method in my </a:t>
-            </a:r>
-            <a:r>
-              <a:rPr lang="en-US" dirty="0" err="1"/>
-              <a:t>IssueService</a:t>
-            </a:r>
-            <a:r>
-              <a:rPr lang="en-US" dirty="0"/>
-              <a:t> class. Let me break it down step by step because there's a lot happening here."</a:t>
-            </a:r>
-          </a:p>
-          <a:p>
-            <a:r>
-              <a:rPr lang="en-US" i="1" dirty="0"/>
-              <a:t>Point to the method signature at the top:</a:t>
-            </a:r>
-            <a:endParaRPr lang="en-US" dirty="0"/>
-          </a:p>
-          <a:p>
-            <a:r>
-              <a:rPr lang="en-US" dirty="0"/>
-              <a:t>"This method is called </a:t>
-            </a:r>
-            <a:r>
-              <a:rPr lang="en-US" sz="1200" kern="1200" dirty="0" err="1">
-                <a:solidFill>
-                  <a:schemeClr val="tx1"/>
-                </a:solidFill>
-                <a:latin typeface="+mn-lt"/>
-                <a:ea typeface="+mn-ea"/>
-                <a:cs typeface="+mn-cs"/>
-              </a:rPr>
-              <a:t>updateStatus</a:t>
-            </a:r>
-            <a:r>
-              <a:rPr lang="en-US" dirty="0"/>
-              <a:t>. It takes three things — the ID of the issue being updated, the new status we want to set it to, and the user who is making the change. In Java, </a:t>
-            </a:r>
-            <a:r>
-              <a:rPr lang="en-US" sz="1200" kern="1200" dirty="0">
-                <a:solidFill>
-                  <a:schemeClr val="tx1"/>
-                </a:solidFill>
-                <a:latin typeface="+mn-lt"/>
-                <a:ea typeface="+mn-ea"/>
-                <a:cs typeface="+mn-cs"/>
-              </a:rPr>
-              <a:t>Long</a:t>
-            </a:r>
-            <a:r>
-              <a:rPr lang="en-US" dirty="0"/>
-              <a:t> just means a number — it's the ID. </a:t>
-            </a:r>
-            <a:r>
-              <a:rPr lang="en-US" sz="1200" kern="1200" dirty="0" err="1">
-                <a:solidFill>
-                  <a:schemeClr val="tx1"/>
-                </a:solidFill>
-                <a:latin typeface="+mn-lt"/>
-                <a:ea typeface="+mn-ea"/>
-                <a:cs typeface="+mn-cs"/>
-              </a:rPr>
-              <a:t>IssueStatus</a:t>
-            </a:r>
-            <a:r>
-              <a:rPr lang="en-US" dirty="0"/>
-              <a:t> is an </a:t>
-            </a:r>
-            <a:r>
-              <a:rPr lang="en-US" dirty="0" err="1"/>
-              <a:t>enum</a:t>
-            </a:r>
-            <a:r>
-              <a:rPr lang="en-US" dirty="0"/>
-              <a:t>, which means it can only be one of four specific values: TODO, IN_PROGRESS, IN_REVIEW, or DONE."</a:t>
-            </a:r>
-          </a:p>
-          <a:p>
-            <a:r>
-              <a:rPr lang="en-US" i="1" dirty="0"/>
-              <a:t>Point to the first comment block:</a:t>
-            </a:r>
-            <a:endParaRPr lang="en-US" dirty="0"/>
-          </a:p>
-          <a:p>
-            <a:r>
-              <a:rPr lang="en-US" dirty="0"/>
-              <a:t>"The first thing this method does — before changing anything — is write a record to a table called </a:t>
-            </a:r>
-            <a:r>
-              <a:rPr lang="en-US" dirty="0" err="1"/>
-              <a:t>issue_history</a:t>
-            </a:r>
-            <a:r>
-              <a:rPr lang="en-US" dirty="0"/>
-              <a:t>. Think of it like a diary entry. It records what field changed — in this case 'status' — what the old value was, what the new value is, who made the change, and when. The reason I save this FIRST is because if anything goes wrong later, the whole transaction rolls back together. Nothing gets saved halfway."</a:t>
-            </a:r>
-          </a:p>
-          <a:p>
-            <a:r>
-              <a:rPr lang="en-US" i="1" dirty="0"/>
-              <a:t>Point to the second block:</a:t>
-            </a:r>
-            <a:endParaRPr lang="en-US" dirty="0"/>
-          </a:p>
-          <a:p>
-            <a:r>
-              <a:rPr lang="en-US" dirty="0"/>
-              <a:t>"Then I actually update the status on the issue and save it to the database."</a:t>
-            </a:r>
-          </a:p>
-          <a:p>
-            <a:r>
-              <a:rPr lang="en-US" i="1" dirty="0"/>
-              <a:t>Point to the third block:</a:t>
-            </a:r>
-            <a:endParaRPr lang="en-US" dirty="0"/>
-          </a:p>
-          <a:p>
-            <a:r>
-              <a:rPr lang="en-US" dirty="0"/>
-              <a:t>"The last thing I do is send a notification — but only under a specific condition. I check whether the issue has an assignee. Then I check whether the person who made the change is a different person from the assignee. If someone else moved your issue, you get notified. But if you moved your own issue, you don't get a notification — because that would be annoying. That was a deliberate design decision I made."</a:t>
-            </a:r>
-          </a:p>
-          <a:p>
-            <a:r>
-              <a:rPr lang="en-US" i="1" dirty="0"/>
-              <a:t>Point to the four cards on the right:</a:t>
-            </a:r>
-            <a:endParaRPr lang="en-US" dirty="0"/>
-          </a:p>
-          <a:p>
-            <a:r>
-              <a:rPr lang="en-US" dirty="0"/>
-              <a:t>"This one method shows four things I'm really proud of. First — the audit trail. Every status change is permanently recorded. Second — smart notifications that only fire when they're actually useful. Third — role-based guards that check if you have permission before allowing sensitive actions. </a:t>
-            </a:r>
-          </a:p>
-          <a:p>
             <a:endParaRPr lang="en-US" dirty="0"/>
           </a:p>
         </p:txBody>
@@ -1324,76 +1047,6 @@
           <a:bodyPr/>
           <a:lstStyle/>
           <a:p>
-            <a:r>
-              <a:rPr lang="en-US" dirty="0"/>
-              <a:t>Let me explain how logging in works. When you send your email and password to the login endpoint, the password gets checked against a hashed version stored in the database using something called </a:t>
-            </a:r>
-            <a:r>
-              <a:rPr lang="en-US" dirty="0" err="1"/>
-              <a:t>BCrypt</a:t>
-            </a:r>
-            <a:r>
-              <a:rPr lang="en-US" dirty="0"/>
-              <a:t>. Hashing means the password is scrambled in a one-way process — so even if someone got into the database, they couldn't read anyone's password. If the password matches, the server creates a JWT token and sends it back to you."</a:t>
-            </a:r>
-          </a:p>
-          <a:p>
-            <a:r>
-              <a:rPr lang="en-US" dirty="0"/>
-              <a:t>"JWT stands for JSON Web Token. Think of it like a wristband at an event — once you have it, you show it with every request you make, and the server knows who you are without having to check the database every time. The token expires after 24 hours."</a:t>
-            </a:r>
-          </a:p>
-          <a:p>
-            <a:r>
-              <a:rPr lang="en-US" i="1" dirty="0"/>
-              <a:t>Point to the security grid:</a:t>
-            </a:r>
-            <a:endParaRPr lang="en-US" dirty="0"/>
-          </a:p>
-          <a:p>
-            <a:r>
-              <a:rPr lang="en-US" dirty="0"/>
-              <a:t>"On the security side — passwords are always hashed, never stored in plain text. The JWT is stateless, meaning the server doesn't store any session information. CORS is configured to only allow requests from my frontend. I also added rate limiting on the login endpoint — if someone tries to log in more than 10 times in a minute, they get blocked. This prevents brute force attacks where someone writes a script to guess your password thousands of times."</a:t>
-            </a:r>
-          </a:p>
-          <a:p>
-            <a:r>
-              <a:rPr lang="en-US" i="1" dirty="0"/>
-              <a:t>Point to the setup grid:</a:t>
-            </a:r>
-            <a:endParaRPr lang="en-US" dirty="0"/>
-          </a:p>
-          <a:p>
-            <a:r>
-              <a:rPr lang="en-US" dirty="0"/>
-              <a:t>"For local setup — MySQL runs on port 3306, the database schema is in a file called </a:t>
-            </a:r>
-            <a:r>
-              <a:rPr lang="en-US" dirty="0" err="1"/>
-              <a:t>Cairo.sql</a:t>
-            </a:r>
-            <a:r>
-              <a:rPr lang="en-US" dirty="0"/>
-              <a:t>, and I have seed data in </a:t>
-            </a:r>
-            <a:r>
-              <a:rPr lang="en-US" dirty="0" err="1"/>
-              <a:t>seed.sql</a:t>
-            </a:r>
-            <a:r>
-              <a:rPr lang="en-US" dirty="0"/>
-              <a:t> that pre-loads 4 users and 14 issues so the app has real data to demo. You start the backend with one Maven command and the frontend with </a:t>
-            </a:r>
-            <a:r>
-              <a:rPr lang="en-US" dirty="0" err="1"/>
-              <a:t>npm</a:t>
-            </a:r>
-            <a:r>
-              <a:rPr lang="en-US" dirty="0"/>
-              <a:t> run dev.</a:t>
-            </a:r>
-          </a:p>
-          <a:p>
             <a:endParaRPr lang="en-US" dirty="0"/>
           </a:p>
         </p:txBody>
@@ -1477,54 +1130,6 @@
         <p:txBody>
           <a:bodyPr/>
           <a:lstStyle/>
-          <a:p>
-            <a:r>
-              <a:rPr lang="en-US" dirty="0"/>
-              <a:t>I want to share three lessons I took away from this build."</a:t>
-            </a:r>
-          </a:p>
-          <a:p>
-            <a:r>
-              <a:rPr lang="en-US" dirty="0"/>
-              <a:t>"</a:t>
-            </a:r>
-            <a:r>
-              <a:rPr lang="en-US" b="1" dirty="0"/>
-              <a:t>First — design your database before you write code.</a:t>
-            </a:r>
-            <a:r>
-              <a:rPr lang="en-US" dirty="0"/>
-              <a:t> I spent Day 1 drawing out the full database diagram before touching any code. Because of that, I never had to change a single table during the entire build. Honestly I'm used to just figuring things out as I go — but designing first helped me stay organized and keep everything simple and to the point. It's a habit I'm taking with me."</a:t>
-            </a:r>
-          </a:p>
-          <a:p>
-            <a:r>
-              <a:rPr lang="en-US" dirty="0"/>
-              <a:t>"</a:t>
-            </a:r>
-            <a:r>
-              <a:rPr lang="en-US" b="1" dirty="0"/>
-              <a:t>Second — handle your errors properly.</a:t>
-            </a:r>
-            <a:r>
-              <a:rPr lang="en-US" dirty="0"/>
-              <a:t> When someone typed the wrong password, my app was returning a 500 Internal Server Error instead of a 401 Unauthorized. A 500 means the server crashed — which is confusing and looks unprofessional. One extra exception handler fixed it and made the API respond correctly. Small fix, big difference."</a:t>
-            </a:r>
-          </a:p>
-          <a:p>
-            <a:r>
-              <a:rPr lang="en-US" dirty="0"/>
-              <a:t>"</a:t>
-            </a:r>
-            <a:r>
-              <a:rPr lang="en-US" b="1" dirty="0"/>
-              <a:t>Third — when a tool fails, build it yourself.</a:t>
-            </a:r>
-            <a:r>
-              <a:rPr lang="en-US" dirty="0"/>
-              <a:t> The animation library I was supposed to use for the background on my login page wouldn't install. So I wrote the entire animation from scratch using the HTML canvas. That turned out to be the better outcome — because now I understand every single line of it and I own it completely.</a:t>
-            </a:r>
-          </a:p>
           <a:p>
             <a:endParaRPr lang="en-US" dirty="0"/>
           </a:p>

</xml_diff>